<commit_message>
Ajoute les captures du board au support et au rapport final
Slide 4 du support : captures du board au début et à la fin du sprint.
Rapport : la capture de fin rejoint celle du début dans l'annexe A,
le journal des daily passe sur une nouvelle page. PDF régénérés.

Co-Authored-By: Claude Opus 5.5 <noreply@anthropic.com>
</commit_message>
<xml_diff>
--- a/docs/06-sprint-review/support-demonstration.pptx
+++ b/docs/06-sprint-review/support-demonstration.pptx
@@ -5513,11 +5513,11 @@
         <p:spPr>
           <a:xfrm>
             <a:off x="548640" y="1371600"/>
-            <a:ext cx="5394960" cy="1874519"/>
+            <a:ext cx="5394960" cy="1024128"/>
           </a:xfrm>
           <a:prstGeom prst="roundRect">
             <a:avLst>
-              <a:gd name="adj" fmla="val 7000"/>
+              <a:gd name="adj" fmla="val 12800"/>
             </a:avLst>
           </a:prstGeom>
           <a:solidFill>
@@ -5558,8 +5558,8 @@
         </p:nvSpPr>
         <p:spPr>
           <a:xfrm>
-            <a:off x="822959" y="1645920"/>
-            <a:ext cx="502920" cy="502920"/>
+            <a:off x="804672" y="1655064"/>
+            <a:ext cx="457200" cy="457200"/>
           </a:xfrm>
           <a:prstGeom prst="ellipse">
             <a:avLst/>
@@ -5592,7 +5592,7 @@
           <a:p>
             <a:pPr algn="ctr"/>
             <a:r>
-              <a:rPr sz="1600" b="1">
+              <a:rPr sz="1500" b="1">
                 <a:solidFill>
                   <a:srgbClr val="FFFFFF"/>
                 </a:solidFill>
@@ -5611,8 +5611,8 @@
         </p:nvSpPr>
         <p:spPr>
           <a:xfrm>
-            <a:off x="1554480" y="1645920"/>
-            <a:ext cx="4114800" cy="502920"/>
+            <a:off x="1481328" y="1490472"/>
+            <a:ext cx="4206240" cy="310896"/>
           </a:xfrm>
           <a:prstGeom prst="rect">
             <a:avLst/>
@@ -5627,7 +5627,7 @@
           <a:p>
             <a:pPr algn="l"/>
             <a:r>
-              <a:rPr sz="2200" b="1">
+              <a:rPr sz="2000" b="1">
                 <a:solidFill>
                   <a:srgbClr val="1A1B33"/>
                 </a:solidFill>
@@ -5646,8 +5646,8 @@
         </p:nvSpPr>
         <p:spPr>
           <a:xfrm>
-            <a:off x="1554480" y="2240280"/>
-            <a:ext cx="4114800" cy="914400"/>
+            <a:off x="1481328" y="1837943"/>
+            <a:ext cx="4206240" cy="457200"/>
           </a:xfrm>
           <a:prstGeom prst="rect">
             <a:avLst/>
@@ -5662,7 +5662,7 @@
           <a:p>
             <a:pPr algn="l"/>
             <a:r>
-              <a:rPr sz="1700" b="0">
+              <a:rPr sz="1500" b="0">
                 <a:solidFill>
                   <a:srgbClr val="1A1B33"/>
                 </a:solidFill>
@@ -5682,11 +5682,11 @@
         <p:spPr>
           <a:xfrm>
             <a:off x="6217920" y="1371600"/>
-            <a:ext cx="5394960" cy="1874519"/>
+            <a:ext cx="5394960" cy="1024128"/>
           </a:xfrm>
           <a:prstGeom prst="roundRect">
             <a:avLst>
-              <a:gd name="adj" fmla="val 7000"/>
+              <a:gd name="adj" fmla="val 12800"/>
             </a:avLst>
           </a:prstGeom>
           <a:solidFill>
@@ -5727,8 +5727,8 @@
         </p:nvSpPr>
         <p:spPr>
           <a:xfrm>
-            <a:off x="6492240" y="1645920"/>
-            <a:ext cx="502920" cy="502920"/>
+            <a:off x="6473952" y="1655064"/>
+            <a:ext cx="457200" cy="457200"/>
           </a:xfrm>
           <a:prstGeom prst="ellipse">
             <a:avLst/>
@@ -5761,7 +5761,7 @@
           <a:p>
             <a:pPr algn="ctr"/>
             <a:r>
-              <a:rPr sz="1600" b="1">
+              <a:rPr sz="1500" b="1">
                 <a:solidFill>
                   <a:srgbClr val="FFFFFF"/>
                 </a:solidFill>
@@ -5780,8 +5780,8 @@
         </p:nvSpPr>
         <p:spPr>
           <a:xfrm>
-            <a:off x="7223760" y="1645920"/>
-            <a:ext cx="4114800" cy="502920"/>
+            <a:off x="7150608" y="1490472"/>
+            <a:ext cx="4206240" cy="310896"/>
           </a:xfrm>
           <a:prstGeom prst="rect">
             <a:avLst/>
@@ -5796,7 +5796,7 @@
           <a:p>
             <a:pPr algn="l"/>
             <a:r>
-              <a:rPr sz="2200" b="1">
+              <a:rPr sz="2000" b="1">
                 <a:solidFill>
                   <a:srgbClr val="1A1B33"/>
                 </a:solidFill>
@@ -5815,8 +5815,8 @@
         </p:nvSpPr>
         <p:spPr>
           <a:xfrm>
-            <a:off x="7223760" y="2240280"/>
-            <a:ext cx="4114800" cy="914400"/>
+            <a:off x="7150608" y="1837943"/>
+            <a:ext cx="4206240" cy="457200"/>
           </a:xfrm>
           <a:prstGeom prst="rect">
             <a:avLst/>
@@ -5831,7 +5831,7 @@
           <a:p>
             <a:pPr algn="l"/>
             <a:r>
-              <a:rPr sz="1700" b="0">
+              <a:rPr sz="1500" b="0">
                 <a:solidFill>
                   <a:srgbClr val="1A1B33"/>
                 </a:solidFill>
@@ -5850,12 +5850,12 @@
         </p:nvSpPr>
         <p:spPr>
           <a:xfrm>
-            <a:off x="548640" y="3474720"/>
-            <a:ext cx="5394960" cy="1874519"/>
+            <a:off x="548640" y="2532888"/>
+            <a:ext cx="5394960" cy="1024128"/>
           </a:xfrm>
           <a:prstGeom prst="roundRect">
             <a:avLst>
-              <a:gd name="adj" fmla="val 7000"/>
+              <a:gd name="adj" fmla="val 12800"/>
             </a:avLst>
           </a:prstGeom>
           <a:solidFill>
@@ -5896,8 +5896,8 @@
         </p:nvSpPr>
         <p:spPr>
           <a:xfrm>
-            <a:off x="822959" y="3749039"/>
-            <a:ext cx="502920" cy="502920"/>
+            <a:off x="804672" y="2816352"/>
+            <a:ext cx="457200" cy="457200"/>
           </a:xfrm>
           <a:prstGeom prst="ellipse">
             <a:avLst/>
@@ -5930,7 +5930,7 @@
           <a:p>
             <a:pPr algn="ctr"/>
             <a:r>
-              <a:rPr sz="1600" b="1">
+              <a:rPr sz="1500" b="1">
                 <a:solidFill>
                   <a:srgbClr val="FFFFFF"/>
                 </a:solidFill>
@@ -5949,8 +5949,8 @@
         </p:nvSpPr>
         <p:spPr>
           <a:xfrm>
-            <a:off x="1554480" y="3749039"/>
-            <a:ext cx="4114800" cy="502920"/>
+            <a:off x="1481328" y="2651760"/>
+            <a:ext cx="4206240" cy="310896"/>
           </a:xfrm>
           <a:prstGeom prst="rect">
             <a:avLst/>
@@ -5965,7 +5965,7 @@
           <a:p>
             <a:pPr algn="l"/>
             <a:r>
-              <a:rPr sz="2200" b="1">
+              <a:rPr sz="2000" b="1">
                 <a:solidFill>
                   <a:srgbClr val="1A1B33"/>
                 </a:solidFill>
@@ -5984,8 +5984,8 @@
         </p:nvSpPr>
         <p:spPr>
           <a:xfrm>
-            <a:off x="1554480" y="4343400"/>
-            <a:ext cx="4114800" cy="914400"/>
+            <a:off x="1481328" y="2999232"/>
+            <a:ext cx="4206240" cy="457200"/>
           </a:xfrm>
           <a:prstGeom prst="rect">
             <a:avLst/>
@@ -6000,7 +6000,7 @@
           <a:p>
             <a:pPr algn="l"/>
             <a:r>
-              <a:rPr sz="1700" b="0">
+              <a:rPr sz="1500" b="0">
                 <a:solidFill>
                   <a:srgbClr val="1A1B33"/>
                 </a:solidFill>
@@ -6019,12 +6019,12 @@
         </p:nvSpPr>
         <p:spPr>
           <a:xfrm>
-            <a:off x="6217920" y="3474720"/>
-            <a:ext cx="5394960" cy="1874519"/>
+            <a:off x="6217920" y="2532888"/>
+            <a:ext cx="5394960" cy="1024128"/>
           </a:xfrm>
           <a:prstGeom prst="roundRect">
             <a:avLst>
-              <a:gd name="adj" fmla="val 7000"/>
+              <a:gd name="adj" fmla="val 12800"/>
             </a:avLst>
           </a:prstGeom>
           <a:solidFill>
@@ -6065,8 +6065,8 @@
         </p:nvSpPr>
         <p:spPr>
           <a:xfrm>
-            <a:off x="6492240" y="3749039"/>
-            <a:ext cx="502920" cy="502920"/>
+            <a:off x="6473952" y="2816352"/>
+            <a:ext cx="457200" cy="457200"/>
           </a:xfrm>
           <a:prstGeom prst="ellipse">
             <a:avLst/>
@@ -6099,7 +6099,7 @@
           <a:p>
             <a:pPr algn="ctr"/>
             <a:r>
-              <a:rPr sz="1600" b="1">
+              <a:rPr sz="1500" b="1">
                 <a:solidFill>
                   <a:srgbClr val="FFFFFF"/>
                 </a:solidFill>
@@ -6118,8 +6118,8 @@
         </p:nvSpPr>
         <p:spPr>
           <a:xfrm>
-            <a:off x="7223760" y="3749039"/>
-            <a:ext cx="4114800" cy="502920"/>
+            <a:off x="7150608" y="2651760"/>
+            <a:ext cx="4206240" cy="310896"/>
           </a:xfrm>
           <a:prstGeom prst="rect">
             <a:avLst/>
@@ -6134,7 +6134,7 @@
           <a:p>
             <a:pPr algn="l"/>
             <a:r>
-              <a:rPr sz="2200" b="1">
+              <a:rPr sz="2000" b="1">
                 <a:solidFill>
                   <a:srgbClr val="1A1B33"/>
                 </a:solidFill>
@@ -6153,8 +6153,8 @@
         </p:nvSpPr>
         <p:spPr>
           <a:xfrm>
-            <a:off x="7223760" y="4343400"/>
-            <a:ext cx="4114800" cy="914400"/>
+            <a:off x="7150608" y="2999232"/>
+            <a:ext cx="4206240" cy="457200"/>
           </a:xfrm>
           <a:prstGeom prst="rect">
             <a:avLst/>
@@ -6169,7 +6169,7 @@
           <a:p>
             <a:pPr algn="l"/>
             <a:r>
-              <a:rPr sz="1700" b="0">
+              <a:rPr sz="1500" b="0">
                 <a:solidFill>
                   <a:srgbClr val="1A1B33"/>
                 </a:solidFill>
@@ -6188,7 +6188,7 @@
         </p:nvSpPr>
         <p:spPr>
           <a:xfrm>
-            <a:off x="548640" y="5852160"/>
+            <a:off x="548640" y="6117336"/>
             <a:ext cx="11064240" cy="457200"/>
           </a:xfrm>
           <a:prstGeom prst="rect">
@@ -6259,6 +6259,150 @@
           </a:p>
         </p:txBody>
       </p:sp>
+      <p:sp>
+        <p:nvSpPr>
+          <p:cNvPr id="21" name="TextBox 20"/>
+          <p:cNvSpPr txBox="1"/>
+          <p:nvPr/>
+        </p:nvSpPr>
+        <p:spPr>
+          <a:xfrm>
+            <a:off x="548640" y="3685032"/>
+            <a:ext cx="5394960" cy="256032"/>
+          </a:xfrm>
+          <a:prstGeom prst="rect">
+            <a:avLst/>
+          </a:prstGeom>
+          <a:noFill/>
+        </p:spPr>
+        <p:txBody>
+          <a:bodyPr wrap="square" lIns="0" rIns="0" tIns="0" bIns="0">
+            <a:spAutoFit/>
+          </a:bodyPr>
+          <a:lstStyle/>
+          <a:p>
+            <a:r>
+              <a:rPr sz="1500" b="1">
+                <a:solidFill>
+                  <a:srgbClr val="3E4CB6"/>
+                </a:solidFill>
+                <a:latin typeface="Calibri"/>
+              </a:rPr>
+              <a:t>Début du sprint</a:t>
+            </a:r>
+            <a:r>
+              <a:rPr sz="1500" b="0">
+                <a:solidFill>
+                  <a:srgbClr val="1A1B33"/>
+                </a:solidFill>
+                <a:latin typeface="Calibri"/>
+              </a:rPr>
+              <a:t> : les 30 cartes sont à faire.</a:t>
+            </a:r>
+          </a:p>
+        </p:txBody>
+      </p:sp>
+      <p:pic>
+        <p:nvPicPr>
+          <p:cNvPr id="22" name="Picture 21" descr="Board GitHub au début du sprint : 30 cartes dans la colonne À faire"/>
+          <p:cNvPicPr>
+            <a:picLocks noChangeAspect="1"/>
+          </p:cNvPicPr>
+          <p:nvPr/>
+        </p:nvPicPr>
+        <p:blipFill>
+          <a:blip r:embed="rId3"/>
+          <a:stretch>
+            <a:fillRect/>
+          </a:stretch>
+        </p:blipFill>
+        <p:spPr>
+          <a:xfrm>
+            <a:off x="548640" y="4014216"/>
+            <a:ext cx="4487237" cy="1920240"/>
+          </a:xfrm>
+          <a:prstGeom prst="rect">
+            <a:avLst/>
+          </a:prstGeom>
+          <a:ln w="12700">
+            <a:solidFill>
+              <a:srgbClr val="D9DBEA"/>
+            </a:solidFill>
+          </a:ln>
+        </p:spPr>
+      </p:pic>
+      <p:sp>
+        <p:nvSpPr>
+          <p:cNvPr id="23" name="TextBox 22"/>
+          <p:cNvSpPr txBox="1"/>
+          <p:nvPr/>
+        </p:nvSpPr>
+        <p:spPr>
+          <a:xfrm>
+            <a:off x="6217920" y="3685032"/>
+            <a:ext cx="5394960" cy="256032"/>
+          </a:xfrm>
+          <a:prstGeom prst="rect">
+            <a:avLst/>
+          </a:prstGeom>
+          <a:noFill/>
+        </p:spPr>
+        <p:txBody>
+          <a:bodyPr wrap="square" lIns="0" rIns="0" tIns="0" bIns="0">
+            <a:spAutoFit/>
+          </a:bodyPr>
+          <a:lstStyle/>
+          <a:p>
+            <a:r>
+              <a:rPr sz="1500" b="1">
+                <a:solidFill>
+                  <a:srgbClr val="3E4CB6"/>
+                </a:solidFill>
+                <a:latin typeface="Calibri"/>
+              </a:rPr>
+              <a:t>Fin du sprint</a:t>
+            </a:r>
+            <a:r>
+              <a:rPr sz="1500" b="0">
+                <a:solidFill>
+                  <a:srgbClr val="1A1B33"/>
+                </a:solidFill>
+                <a:latin typeface="Calibri"/>
+              </a:rPr>
+              <a:t> : 29 cartes terminées, il reste la remise du dossier.</a:t>
+            </a:r>
+          </a:p>
+        </p:txBody>
+      </p:sp>
+      <p:pic>
+        <p:nvPicPr>
+          <p:cNvPr id="24" name="Picture 23" descr="Board GitHub à la fin du sprint : 29 cartes dans Terminé, 1 dans À faire"/>
+          <p:cNvPicPr>
+            <a:picLocks noChangeAspect="1"/>
+          </p:cNvPicPr>
+          <p:nvPr/>
+        </p:nvPicPr>
+        <p:blipFill>
+          <a:blip r:embed="rId4"/>
+          <a:stretch>
+            <a:fillRect/>
+          </a:stretch>
+        </p:blipFill>
+        <p:spPr>
+          <a:xfrm>
+            <a:off x="6217920" y="4014216"/>
+            <a:ext cx="4538233" cy="1920240"/>
+          </a:xfrm>
+          <a:prstGeom prst="rect">
+            <a:avLst/>
+          </a:prstGeom>
+          <a:ln w="12700">
+            <a:solidFill>
+              <a:srgbClr val="D9DBEA"/>
+            </a:solidFill>
+          </a:ln>
+        </p:spPr>
+      </p:pic>
     </p:spTree>
   </p:cSld>
   <p:clrMapOvr>

</xml_diff>

<commit_message>
Aligne le rapport, le support et le journal sur l'historique du dépôt
Relecture des PR : présentée comme la règle, avec le compte réel du sprint
(7 PR relues sur 9). Journal : la ligne du J3 retrouve les valeurs du
premier fichier (178 commandes), une note indique le recalcul du J4.

Co-Authored-By: Claude Opus 5.5 <noreply@anthropic.com>
</commit_message>
<xml_diff>
--- a/docs/06-sprint-review/support-demonstration.pptx
+++ b/docs/06-sprint-review/support-demonstration.pptx
@@ -5837,7 +5837,7 @@
                 </a:solidFill>
                 <a:latin typeface="Calibri"/>
               </a:rPr>
-              <a:t>Fait hier, prévu aujourd'hui, obstacles. Le journal est tenu chaque jour.</a:t>
+              <a:t>Fait hier, prévu aujourd'hui, obstacles. Les réponses sont notées dans le journal.</a:t>
             </a:r>
           </a:p>
         </p:txBody>
@@ -6006,7 +6006,7 @@
                 </a:solidFill>
                 <a:latin typeface="Calibri"/>
               </a:rPr>
-              <a:t>Chaque ajout au dépôt est relu par un autre membre avant d'être fusionné.</a:t>
+              <a:t>La règle : toute pull request est relue par un autre membre avant d'être fusionnée.</a:t>
             </a:r>
           </a:p>
         </p:txBody>

</xml_diff>

<commit_message>
Écrit les noms complets des trois membres
Rapport (en-tête et tableau de l'équipe), support de démonstration
(slide 1), README et fiche projet : Isselmou Sidi OUMOU, Ndeye Sokhna
NOKHO, Ibrahima Gabar DIOP. Avant, un seul membre avait son nom de
famille. PDF régénérés.

Co-Authored-By: Claude Opus 5.5 <noreply@anthropic.com>
</commit_message>
<xml_diff>
--- a/docs/06-sprint-review/support-demonstration.pptx
+++ b/docs/06-sprint-review/support-demonstration.pptx
@@ -4169,7 +4169,7 @@
         </p:nvSpPr>
         <p:spPr>
           <a:xfrm>
-            <a:off x="731520" y="5806440"/>
+            <a:off x="731520" y="5550408"/>
             <a:ext cx="5669280" cy="640080"/>
           </a:xfrm>
           <a:prstGeom prst="rect">
@@ -4191,7 +4191,7 @@
                 </a:solidFill>
                 <a:latin typeface="Calibri"/>
               </a:rPr>
-              <a:t>Isselmou, Product Owner  ·  Ndeye Sokhna, Scrum Master</a:t>
+              <a:t>Isselmou Sidi OUMOU, Product Owner</a:t>
             </a:r>
           </a:p>
           <a:p>
@@ -4207,7 +4207,23 @@
                 </a:solidFill>
                 <a:latin typeface="Calibri"/>
               </a:rPr>
-              <a:t>Ibrahima, équipe de réalisation  ·  M1 MBDA, UN-CHK</a:t>
+              <a:t>Ndeye Sokhna NOKHO, Scrum Master</a:t>
+            </a:r>
+          </a:p>
+          <a:p>
+            <a:pPr algn="l">
+              <a:spcBef>
+                <a:spcPts val="300"/>
+              </a:spcBef>
+            </a:pPr>
+            <a:r>
+              <a:rPr sz="1400" b="0">
+                <a:solidFill>
+                  <a:srgbClr val="B9BDDD"/>
+                </a:solidFill>
+                <a:latin typeface="Calibri"/>
+              </a:rPr>
+              <a:t>Ibrahima Gabar DIOP, équipe de réalisation  ·  M1 MBDA, UN-CHK</a:t>
             </a:r>
           </a:p>
         </p:txBody>

</xml_diff>